<commit_message>
Add Step 3: ten most popular directors
- Rerun the Part 2 genre, runtime, and profile queries on films by the ten
  most-voted directors, de-duplicating director-film pairs first
- Add a documentary vs. other-films split per director and a genre-mix
  comparison against the full catalog, with Step 3 findings
- Add cleaning task 11: 43.8% of rows in the directors table are duplicates
- Update the deck: Scorsese documentary check on slide 3, eleven cleaning
  tasks on slide 5
</commit_message>
<xml_diff>
--- a/Part2_Presentation.pptx
+++ b/Part2_Presentation.pptx
@@ -682,7 +682,7 @@
           <a:p>
             <a:r>
               <a:rPr lang="en-US" dirty="0"/>
-              <a:t>Each bubble is a genre. Left to right is how often a rated title in that genre reaches at least 1,000 votes; bottom to top is its average rating. Documentary is the paradox: the most titles made and the best reviewed, but only 4.2 percent of rated documentaries find an audience. Action and Crime reach one 28.6 percent of the time. The full chart with every genre labeled is in the notebook.</a:t>
+              <a:t>Each bubble is a genre. Left to right is how often a rated title in that genre reaches at least 1,000 votes, and bottom to top is its average rating. Documentary has the most titles and the best ratings, but only 4.2 percent of rated documentaries find an audience. Action and Crime reach one 28.6 percent of the time. I also checked the ten most-voted directors. The only documentaries among their films are Martin Scorsese's, and they average 3,034 votes against 602,857 for his other films, at similar ratings. So it isn't just that documentaries come from less famous filmmakers. The full chart with every genre labeled is in the notebook.</a:t>
             </a:r>
             <a:endParaRPr lang="en-US" dirty="0"/>
           </a:p>
@@ -858,7 +858,7 @@
           <a:p>
             <a:r>
               <a:rPr lang="en-US" dirty="0"/>
-              <a:t>These are the cleaning tasks a deeper analysis would need, grouped by type. The two the brief emphasizes are normalization, mainly splitting the genres field into its own table, and null handling, where rows missing a value are excluded rather than filled in. Every number on this slide comes from a query in the notebook.</a:t>
+              <a:t>These are the cleaning tasks a deeper analysis would need, grouped by type. The two the brief emphasizes are normalization, mainly splitting the genres field into its own table, and null handling, where rows missing a value are excluded rather than filled in. The last one came up while ranking directors: almost 44 percent of the rows in the directors table are duplicates, so any count over directors has to remove them first. Every number on this slide comes from a query in the notebook.</a:t>
             </a:r>
             <a:endParaRPr lang="en-US" dirty="0"/>
           </a:p>
@@ -2464,7 +2464,7 @@
         <p:spPr>
           <a:xfrm>
             <a:off x="6601968" y="1353312"/>
-            <a:ext cx="1920240" cy="274320"/>
+            <a:ext cx="2011680" cy="274320"/>
           </a:xfrm>
           <a:prstGeom prst="rect">
             <a:avLst/>
@@ -2480,7 +2480,7 @@
               <a:buNone/>
             </a:pPr>
             <a:r>
-              <a:rPr lang="en-US" sz="1150" b="1" dirty="0">
+              <a:rPr lang="en-US" sz="1100" b="1" dirty="0">
                 <a:solidFill>
                   <a:srgbClr val="16202E"/>
                 </a:solidFill>
@@ -2490,7 +2490,7 @@
               </a:rPr>
               <a:t>Documentary</a:t>
             </a:r>
-            <a:endParaRPr lang="en-US" sz="1150" dirty="0"/>
+            <a:endParaRPr lang="en-US" sz="1100" dirty="0"/>
           </a:p>
         </p:txBody>
       </p:sp>
@@ -2609,7 +2609,7 @@
             <a:avLst/>
           </a:prstGeom>
           <a:solidFill>
-            <a:srgbClr val="C8641E"/>
+            <a:srgbClr val="2B6CB0"/>
           </a:solidFill>
           <a:ln/>
         </p:spPr>
@@ -2623,7 +2623,7 @@
         <p:spPr>
           <a:xfrm>
             <a:off x="6601968" y="2514600"/>
-            <a:ext cx="1920240" cy="274320"/>
+            <a:ext cx="2011680" cy="274320"/>
           </a:xfrm>
           <a:prstGeom prst="rect">
             <a:avLst/>
@@ -2639,166 +2639,7 @@
               <a:buNone/>
             </a:pPr>
             <a:r>
-              <a:rPr lang="en-US" sz="1150" b="1" dirty="0">
-                <a:solidFill>
-                  <a:srgbClr val="16202E"/>
-                </a:solidFill>
-                <a:latin typeface="Arial" pitchFamily="34" charset="0"/>
-                <a:ea typeface="Arial" pitchFamily="34" charset="-122"/>
-                <a:cs typeface="Arial" pitchFamily="34" charset="-120"/>
-              </a:rPr>
-              <a:t>Drama</a:t>
-            </a:r>
-            <a:endParaRPr lang="en-US" sz="1150" dirty="0"/>
-          </a:p>
-        </p:txBody>
-      </p:sp>
-      <p:sp>
-        <p:nvSpPr>
-          <p:cNvPr id="14" name="Text 11"/>
-          <p:cNvSpPr txBox="1"/>
-          <p:nvPr/>
-        </p:nvSpPr>
-        <p:spPr>
-          <a:xfrm>
-            <a:off x="6355080" y="2852928"/>
-            <a:ext cx="868680" cy="457200"/>
-          </a:xfrm>
-          <a:prstGeom prst="rect">
-            <a:avLst/>
-          </a:prstGeom>
-          <a:noFill/>
-          <a:ln/>
-        </p:spPr>
-        <p:txBody>
-          <a:bodyPr wrap="square" lIns="0" tIns="0" rIns="0" bIns="0" rtlCol="0" anchor="t"/>
-          <a:lstStyle/>
-          <a:p>
-            <a:pPr indent="0" marL="0">
-              <a:buNone/>
-            </a:pPr>
-            <a:r>
-              <a:rPr lang="en-US" sz="2400" b="1" dirty="0">
-                <a:solidFill>
-                  <a:srgbClr val="A5501A"/>
-                </a:solidFill>
-                <a:latin typeface="Oswald" pitchFamily="34" charset="0"/>
-                <a:ea typeface="Oswald" pitchFamily="34" charset="-122"/>
-                <a:cs typeface="Oswald" pitchFamily="34" charset="-120"/>
-              </a:rPr>
-              <a:t>16.4%</a:t>
-            </a:r>
-            <a:endParaRPr lang="en-US" sz="2400" dirty="0"/>
-          </a:p>
-        </p:txBody>
-      </p:sp>
-      <p:sp>
-        <p:nvSpPr>
-          <p:cNvPr id="15" name="Text 12"/>
-          <p:cNvSpPr txBox="1"/>
-          <p:nvPr/>
-        </p:nvSpPr>
-        <p:spPr>
-          <a:xfrm>
-            <a:off x="7223760" y="2825496"/>
-            <a:ext cx="1325880" cy="548640"/>
-          </a:xfrm>
-          <a:prstGeom prst="rect">
-            <a:avLst/>
-          </a:prstGeom>
-          <a:noFill/>
-          <a:ln/>
-        </p:spPr>
-        <p:txBody>
-          <a:bodyPr wrap="square" lIns="0" tIns="0" rIns="0" bIns="0" rtlCol="0" anchor="t"/>
-          <a:lstStyle/>
-          <a:p>
-            <a:pPr indent="0" marL="0">
-              <a:buNone/>
-            </a:pPr>
-            <a:r>
-              <a:rPr lang="en-US" sz="1000" dirty="0">
-                <a:solidFill>
-                  <a:srgbClr val="4A5260"/>
-                </a:solidFill>
-                <a:latin typeface="Arial" pitchFamily="34" charset="0"/>
-                <a:ea typeface="Arial" pitchFamily="34" charset="-122"/>
-                <a:cs typeface="Arial" pitchFamily="34" charset="-120"/>
-              </a:rPr>
-              <a:t>reach across 49,545 titles, below the 18.75% median</a:t>
-            </a:r>
-            <a:endParaRPr lang="en-US" sz="1000" dirty="0"/>
-          </a:p>
-        </p:txBody>
-      </p:sp>
-      <p:sp>
-        <p:nvSpPr>
-          <p:cNvPr id="16" name="Shape 13"/>
-          <p:cNvSpPr/>
-          <p:nvPr/>
-        </p:nvSpPr>
-        <p:spPr>
-          <a:xfrm>
-            <a:off x="6172200" y="3557016"/>
-            <a:ext cx="2514600" cy="1051560"/>
-          </a:xfrm>
-          <a:prstGeom prst="roundRect">
-            <a:avLst>
-              <a:gd name="adj" fmla="val 6957"/>
-            </a:avLst>
-          </a:prstGeom>
-          <a:solidFill>
-            <a:srgbClr val="F2F4F7"/>
-          </a:solidFill>
-          <a:ln/>
-        </p:spPr>
-      </p:sp>
-      <p:sp>
-        <p:nvSpPr>
-          <p:cNvPr id="17" name="Shape 14"/>
-          <p:cNvSpPr/>
-          <p:nvPr/>
-        </p:nvSpPr>
-        <p:spPr>
-          <a:xfrm>
-            <a:off x="6355080" y="3739896"/>
-            <a:ext cx="155448" cy="155448"/>
-          </a:xfrm>
-          <a:prstGeom prst="ellipse">
-            <a:avLst/>
-          </a:prstGeom>
-          <a:solidFill>
-            <a:srgbClr val="2B6CB0"/>
-          </a:solidFill>
-          <a:ln/>
-        </p:spPr>
-      </p:sp>
-      <p:sp>
-        <p:nvSpPr>
-          <p:cNvPr id="18" name="Text 15"/>
-          <p:cNvSpPr txBox="1"/>
-          <p:nvPr/>
-        </p:nvSpPr>
-        <p:spPr>
-          <a:xfrm>
-            <a:off x="6601968" y="3675888"/>
-            <a:ext cx="1920240" cy="274320"/>
-          </a:xfrm>
-          <a:prstGeom prst="rect">
-            <a:avLst/>
-          </a:prstGeom>
-          <a:noFill/>
-          <a:ln/>
-        </p:spPr>
-        <p:txBody>
-          <a:bodyPr wrap="square" lIns="0" tIns="0" rIns="0" bIns="0" rtlCol="0" anchor="ctr"/>
-          <a:lstStyle/>
-          <a:p>
-            <a:pPr indent="0" marL="0">
-              <a:buNone/>
-            </a:pPr>
-            <a:r>
-              <a:rPr lang="en-US" sz="1150" b="1" dirty="0">
+              <a:rPr lang="en-US" sz="1100" b="1" dirty="0">
                 <a:solidFill>
                   <a:srgbClr val="16202E"/>
                 </a:solidFill>
@@ -2808,19 +2649,19 @@
               </a:rPr>
               <a:t>Action &amp; Crime</a:t>
             </a:r>
-            <a:endParaRPr lang="en-US" sz="1150" dirty="0"/>
+            <a:endParaRPr lang="en-US" sz="1100" dirty="0"/>
           </a:p>
         </p:txBody>
       </p:sp>
       <p:sp>
         <p:nvSpPr>
-          <p:cNvPr id="19" name="Text 16"/>
+          <p:cNvPr id="14" name="Text 11"/>
           <p:cNvSpPr txBox="1"/>
           <p:nvPr/>
         </p:nvSpPr>
         <p:spPr>
           <a:xfrm>
-            <a:off x="6355080" y="4014216"/>
+            <a:off x="6355080" y="2852928"/>
             <a:ext cx="868680" cy="457200"/>
           </a:xfrm>
           <a:prstGeom prst="rect">
@@ -2853,13 +2694,13 @@
       </p:sp>
       <p:sp>
         <p:nvSpPr>
-          <p:cNvPr id="20" name="Text 17"/>
+          <p:cNvPr id="15" name="Text 12"/>
           <p:cNvSpPr txBox="1"/>
           <p:nvPr/>
         </p:nvSpPr>
         <p:spPr>
           <a:xfrm>
-            <a:off x="7223760" y="3986784"/>
+            <a:off x="7223760" y="2825496"/>
             <a:ext cx="1325880" cy="548640"/>
           </a:xfrm>
           <a:prstGeom prst="rect">
@@ -2885,6 +2726,165 @@
                 <a:cs typeface="Arial" pitchFamily="34" charset="-120"/>
               </a:rPr>
               <a:t>reach, nearly 7× Documentary on a fraction of its volume</a:t>
+            </a:r>
+            <a:endParaRPr lang="en-US" sz="1000" dirty="0"/>
+          </a:p>
+        </p:txBody>
+      </p:sp>
+      <p:sp>
+        <p:nvSpPr>
+          <p:cNvPr id="16" name="Shape 13"/>
+          <p:cNvSpPr/>
+          <p:nvPr/>
+        </p:nvSpPr>
+        <p:spPr>
+          <a:xfrm>
+            <a:off x="6172200" y="3557016"/>
+            <a:ext cx="2514600" cy="1051560"/>
+          </a:xfrm>
+          <a:prstGeom prst="roundRect">
+            <a:avLst>
+              <a:gd name="adj" fmla="val 6957"/>
+            </a:avLst>
+          </a:prstGeom>
+          <a:solidFill>
+            <a:srgbClr val="F2F4F7"/>
+          </a:solidFill>
+          <a:ln/>
+        </p:spPr>
+      </p:sp>
+      <p:sp>
+        <p:nvSpPr>
+          <p:cNvPr id="17" name="Shape 14"/>
+          <p:cNvSpPr/>
+          <p:nvPr/>
+        </p:nvSpPr>
+        <p:spPr>
+          <a:xfrm>
+            <a:off x="6355080" y="3739896"/>
+            <a:ext cx="155448" cy="155448"/>
+          </a:xfrm>
+          <a:prstGeom prst="ellipse">
+            <a:avLst/>
+          </a:prstGeom>
+          <a:solidFill>
+            <a:srgbClr val="C8641E"/>
+          </a:solidFill>
+          <a:ln/>
+        </p:spPr>
+      </p:sp>
+      <p:sp>
+        <p:nvSpPr>
+          <p:cNvPr id="18" name="Text 15"/>
+          <p:cNvSpPr txBox="1"/>
+          <p:nvPr/>
+        </p:nvSpPr>
+        <p:spPr>
+          <a:xfrm>
+            <a:off x="6601968" y="3675888"/>
+            <a:ext cx="2011680" cy="274320"/>
+          </a:xfrm>
+          <a:prstGeom prst="rect">
+            <a:avLst/>
+          </a:prstGeom>
+          <a:noFill/>
+          <a:ln/>
+        </p:spPr>
+        <p:txBody>
+          <a:bodyPr wrap="square" lIns="0" tIns="0" rIns="0" bIns="0" rtlCol="0" anchor="ctr"/>
+          <a:lstStyle/>
+          <a:p>
+            <a:pPr indent="0" marL="0">
+              <a:buNone/>
+            </a:pPr>
+            <a:r>
+              <a:rPr lang="en-US" sz="1100" b="1" dirty="0">
+                <a:solidFill>
+                  <a:srgbClr val="16202E"/>
+                </a:solidFill>
+                <a:latin typeface="Arial" pitchFamily="34" charset="0"/>
+                <a:ea typeface="Arial" pitchFamily="34" charset="-122"/>
+                <a:cs typeface="Arial" pitchFamily="34" charset="-120"/>
+              </a:rPr>
+              <a:t>Scorsese documentaries</a:t>
+            </a:r>
+            <a:endParaRPr lang="en-US" sz="1100" dirty="0"/>
+          </a:p>
+        </p:txBody>
+      </p:sp>
+      <p:sp>
+        <p:nvSpPr>
+          <p:cNvPr id="19" name="Text 16"/>
+          <p:cNvSpPr txBox="1"/>
+          <p:nvPr/>
+        </p:nvSpPr>
+        <p:spPr>
+          <a:xfrm>
+            <a:off x="6355080" y="4014216"/>
+            <a:ext cx="868680" cy="457200"/>
+          </a:xfrm>
+          <a:prstGeom prst="rect">
+            <a:avLst/>
+          </a:prstGeom>
+          <a:noFill/>
+          <a:ln/>
+        </p:spPr>
+        <p:txBody>
+          <a:bodyPr wrap="square" lIns="0" tIns="0" rIns="0" bIns="0" rtlCol="0" anchor="t"/>
+          <a:lstStyle/>
+          <a:p>
+            <a:pPr indent="0" marL="0">
+              <a:buNone/>
+            </a:pPr>
+            <a:r>
+              <a:rPr lang="en-US" sz="2400" b="1" dirty="0">
+                <a:solidFill>
+                  <a:srgbClr val="A5501A"/>
+                </a:solidFill>
+                <a:latin typeface="Oswald" pitchFamily="34" charset="0"/>
+                <a:ea typeface="Oswald" pitchFamily="34" charset="-122"/>
+                <a:cs typeface="Oswald" pitchFamily="34" charset="-120"/>
+              </a:rPr>
+              <a:t>3,034</a:t>
+            </a:r>
+            <a:endParaRPr lang="en-US" sz="2400" dirty="0"/>
+          </a:p>
+        </p:txBody>
+      </p:sp>
+      <p:sp>
+        <p:nvSpPr>
+          <p:cNvPr id="20" name="Text 17"/>
+          <p:cNvSpPr txBox="1"/>
+          <p:nvPr/>
+        </p:nvSpPr>
+        <p:spPr>
+          <a:xfrm>
+            <a:off x="7223760" y="3986784"/>
+            <a:ext cx="1325880" cy="548640"/>
+          </a:xfrm>
+          <a:prstGeom prst="rect">
+            <a:avLst/>
+          </a:prstGeom>
+          <a:noFill/>
+          <a:ln/>
+        </p:spPr>
+        <p:txBody>
+          <a:bodyPr wrap="square" lIns="0" tIns="0" rIns="0" bIns="0" rtlCol="0" anchor="t"/>
+          <a:lstStyle/>
+          <a:p>
+            <a:pPr indent="0" marL="0">
+              <a:buNone/>
+            </a:pPr>
+            <a:r>
+              <a:rPr lang="en-US" sz="1000" dirty="0">
+                <a:solidFill>
+                  <a:srgbClr val="4A5260"/>
+                </a:solidFill>
+                <a:latin typeface="Arial" pitchFamily="34" charset="0"/>
+                <a:ea typeface="Arial" pitchFamily="34" charset="-122"/>
+                <a:cs typeface="Arial" pitchFamily="34" charset="-120"/>
+              </a:rPr>
+              <a:t>avg votes, vs. 602,857 for his other films</a:t>
             </a:r>
             <a:endParaRPr lang="en-US" sz="1000" dirty="0"/>
           </a:p>
@@ -3620,7 +3620,7 @@
                 <a:ea typeface="Oswald" pitchFamily="34" charset="-122"/>
                 <a:cs typeface="Oswald" pitchFamily="34" charset="-120"/>
               </a:rPr>
-              <a:t>Ten cleaning tasks before a deeper analysis</a:t>
+              <a:t>Eleven cleaning tasks before a deeper analysis</a:t>
             </a:r>
             <a:endParaRPr lang="en-US" sz="2800" dirty="0"/>
           </a:p>
@@ -3641,7 +3641,7 @@
           </p:nvPr>
         </p:nvGraphicFramePr>
         <p:xfrm>
-          <a:off x="457200" y="1325880"/>
+          <a:off x="457200" y="1280160"/>
           <a:ext cx="8229600" cy="914400"/>
         </p:xfrm>
         <a:graphic>
@@ -3653,7 +3653,7 @@
                 <a:gridCol w="3063240"/>
                 <a:gridCol w="3840480"/>
               </a:tblGrid>
-              <a:tr h="265176">
+              <a:tr h="246888">
                 <a:tc>
                   <a:txBody>
                     <a:bodyPr/>
@@ -3663,7 +3663,7 @@
                         <a:buNone/>
                       </a:pPr>
                       <a:r>
-                        <a:rPr lang="en-US" sz="1050" b="1" dirty="0">
+                        <a:rPr lang="en-US" sz="1000" b="1" dirty="0">
                           <a:solidFill>
                             <a:srgbClr val="F4F1EA"/>
                           </a:solidFill>
@@ -3673,14 +3673,14 @@
                         </a:rPr>
                         <a:t>Type</a:t>
                       </a:r>
-                      <a:endParaRPr lang="en-US" sz="1050" dirty="0">
+                      <a:endParaRPr lang="en-US" sz="1000" dirty="0">
                         <a:latin typeface="Arial" charset="0"/>
                         <a:ea typeface="Arial" charset="0"/>
                         <a:cs typeface="Arial" charset="0"/>
                       </a:endParaRPr>
                     </a:p>
                   </a:txBody>
-                  <a:tcPr marL="76200" marR="76200" marT="25400" marB="25400" anchor="ctr">
+                  <a:tcPr marL="76200" marR="76200" marT="12700" marB="12700" anchor="ctr">
                     <a:lnL w="9525" cap="flat" cmpd="sng" algn="ctr">
                       <a:solidFill>
                         <a:srgbClr val="E3E6EB"/>
@@ -3731,7 +3731,7 @@
                         <a:buNone/>
                       </a:pPr>
                       <a:r>
-                        <a:rPr lang="en-US" sz="1050" b="1" dirty="0">
+                        <a:rPr lang="en-US" sz="1000" b="1" dirty="0">
                           <a:solidFill>
                             <a:srgbClr val="F4F1EA"/>
                           </a:solidFill>
@@ -3741,14 +3741,14 @@
                         </a:rPr>
                         <a:t>Task</a:t>
                       </a:r>
-                      <a:endParaRPr lang="en-US" sz="1050" dirty="0">
+                      <a:endParaRPr lang="en-US" sz="1000" dirty="0">
                         <a:latin typeface="Arial" charset="0"/>
                         <a:ea typeface="Arial" charset="0"/>
                         <a:cs typeface="Arial" charset="0"/>
                       </a:endParaRPr>
                     </a:p>
                   </a:txBody>
-                  <a:tcPr marL="76200" marR="76200" marT="25400" marB="25400" anchor="ctr">
+                  <a:tcPr marL="76200" marR="76200" marT="12700" marB="12700" anchor="ctr">
                     <a:lnL w="9525" cap="flat" cmpd="sng" algn="ctr">
                       <a:solidFill>
                         <a:srgbClr val="E3E6EB"/>
@@ -3799,7 +3799,7 @@
                         <a:buNone/>
                       </a:pPr>
                       <a:r>
-                        <a:rPr lang="en-US" sz="1050" b="1" dirty="0">
+                        <a:rPr lang="en-US" sz="1000" b="1" dirty="0">
                           <a:solidFill>
                             <a:srgbClr val="F4F1EA"/>
                           </a:solidFill>
@@ -3809,14 +3809,14 @@
                         </a:rPr>
                         <a:t>Evidence from exploration</a:t>
                       </a:r>
-                      <a:endParaRPr lang="en-US" sz="1050" dirty="0">
+                      <a:endParaRPr lang="en-US" sz="1000" dirty="0">
                         <a:latin typeface="Arial" charset="0"/>
                         <a:ea typeface="Arial" charset="0"/>
                         <a:cs typeface="Arial" charset="0"/>
                       </a:endParaRPr>
                     </a:p>
                   </a:txBody>
-                  <a:tcPr marL="76200" marR="76200" marT="25400" marB="25400" anchor="ctr">
+                  <a:tcPr marL="76200" marR="76200" marT="12700" marB="12700" anchor="ctr">
                     <a:lnL w="9525" cap="flat" cmpd="sng" algn="ctr">
                       <a:solidFill>
                         <a:srgbClr val="E3E6EB"/>
@@ -3859,7 +3859,7 @@
                   </a:tcPr>
                 </a:tc>
               </a:tr>
-              <a:tr h="265176">
+              <a:tr h="246888">
                 <a:tc rowSpan="2">
                   <a:txBody>
                     <a:bodyPr/>
@@ -3869,7 +3869,7 @@
                         <a:buNone/>
                       </a:pPr>
                       <a:r>
-                        <a:rPr lang="en-US" sz="1050" b="1" dirty="0">
+                        <a:rPr lang="en-US" sz="1000" b="1" dirty="0">
                           <a:solidFill>
                             <a:srgbClr val="16202E"/>
                           </a:solidFill>
@@ -3879,14 +3879,14 @@
                         </a:rPr>
                         <a:t>Scope</a:t>
                       </a:r>
-                      <a:endParaRPr lang="en-US" sz="1050" dirty="0">
+                      <a:endParaRPr lang="en-US" sz="1000" dirty="0">
                         <a:latin typeface="Arial" charset="0"/>
                         <a:ea typeface="Arial" charset="0"/>
                         <a:cs typeface="Arial" charset="0"/>
                       </a:endParaRPr>
                     </a:p>
                   </a:txBody>
-                  <a:tcPr marL="76200" marR="76200" marT="25400" marB="25400" anchor="ctr">
+                  <a:tcPr marL="76200" marR="76200" marT="12700" marB="12700" anchor="ctr">
                     <a:lnL w="9525" cap="flat" cmpd="sng" algn="ctr">
                       <a:solidFill>
                         <a:srgbClr val="E3E6EB"/>
@@ -3937,7 +3937,7 @@
                         <a:buNone/>
                       </a:pPr>
                       <a:r>
-                        <a:rPr lang="en-US" sz="1050" dirty="0">
+                        <a:rPr lang="en-US" sz="1000" dirty="0">
                           <a:solidFill>
                             <a:srgbClr val="16202E"/>
                           </a:solidFill>
@@ -3947,14 +3947,14 @@
                         </a:rPr>
                         <a:t>Restrict to 2010–2019 release years</a:t>
                       </a:r>
-                      <a:endParaRPr lang="en-US" sz="1050" dirty="0">
+                      <a:endParaRPr lang="en-US" sz="1000" dirty="0">
                         <a:latin typeface="Arial" charset="0"/>
                         <a:ea typeface="Arial" charset="0"/>
                         <a:cs typeface="Arial" charset="0"/>
                       </a:endParaRPr>
                     </a:p>
                   </a:txBody>
-                  <a:tcPr marL="76200" marR="76200" marT="25400" marB="25400" anchor="ctr">
+                  <a:tcPr marL="76200" marR="76200" marT="12700" marB="12700" anchor="ctr">
                     <a:lnL w="9525" cap="flat" cmpd="sng" algn="ctr">
                       <a:solidFill>
                         <a:srgbClr val="E3E6EB"/>
@@ -4005,7 +4005,7 @@
                         <a:buNone/>
                       </a:pPr>
                       <a:r>
-                        <a:rPr lang="en-US" sz="1050" dirty="0">
+                        <a:rPr lang="en-US" sz="1000" dirty="0">
                           <a:solidFill>
                             <a:srgbClr val="4A5260"/>
                           </a:solidFill>
@@ -4015,14 +4015,14 @@
                         </a:rPr>
                         <a:t>1,063 titles are dated later, one of them 2115</a:t>
                       </a:r>
-                      <a:endParaRPr lang="en-US" sz="1050" dirty="0">
+                      <a:endParaRPr lang="en-US" sz="1000" dirty="0">
                         <a:latin typeface="Arial" charset="0"/>
                         <a:ea typeface="Arial" charset="0"/>
                         <a:cs typeface="Arial" charset="0"/>
                       </a:endParaRPr>
                     </a:p>
                   </a:txBody>
-                  <a:tcPr marL="76200" marR="76200" marT="25400" marB="25400" anchor="ctr">
+                  <a:tcPr marL="76200" marR="76200" marT="12700" marB="12700" anchor="ctr">
                     <a:lnL w="9525" cap="flat" cmpd="sng" algn="ctr">
                       <a:solidFill>
                         <a:srgbClr val="E3E6EB"/>
@@ -4065,7 +4065,7 @@
                   </a:tcPr>
                 </a:tc>
               </a:tr>
-              <a:tr h="265176">
+              <a:tr h="246888">
                 <a:tc vMerge="1">
                   <a:tcPr/>
                 </a:tc>
@@ -4078,7 +4078,7 @@
                         <a:buNone/>
                       </a:pPr>
                       <a:r>
-                        <a:rPr lang="en-US" sz="1050" dirty="0">
+                        <a:rPr lang="en-US" sz="1000" dirty="0">
                           <a:solidFill>
                             <a:srgbClr val="16202E"/>
                           </a:solidFill>
@@ -4088,14 +4088,14 @@
                         </a:rPr>
                         <a:t>Flag 2019 as a partial year</a:t>
                       </a:r>
-                      <a:endParaRPr lang="en-US" sz="1050" dirty="0">
+                      <a:endParaRPr lang="en-US" sz="1000" dirty="0">
                         <a:latin typeface="Arial" charset="0"/>
                         <a:ea typeface="Arial" charset="0"/>
                         <a:cs typeface="Arial" charset="0"/>
                       </a:endParaRPr>
                     </a:p>
                   </a:txBody>
-                  <a:tcPr marL="76200" marR="76200" marT="25400" marB="25400" anchor="ctr">
+                  <a:tcPr marL="76200" marR="76200" marT="12700" marB="12700" anchor="ctr">
                     <a:lnL w="9525" cap="flat" cmpd="sng" algn="ctr">
                       <a:solidFill>
                         <a:srgbClr val="E3E6EB"/>
@@ -4146,7 +4146,7 @@
                         <a:buNone/>
                       </a:pPr>
                       <a:r>
-                        <a:rPr lang="en-US" sz="1050" dirty="0">
+                        <a:rPr lang="en-US" sz="1000" dirty="0">
                           <a:solidFill>
                             <a:srgbClr val="4A5260"/>
                           </a:solidFill>
@@ -4156,14 +4156,14 @@
                         </a:rPr>
                         <a:t>8,379 titles vs 16,849 in 2018</a:t>
                       </a:r>
-                      <a:endParaRPr lang="en-US" sz="1050" dirty="0">
+                      <a:endParaRPr lang="en-US" sz="1000" dirty="0">
                         <a:latin typeface="Arial" charset="0"/>
                         <a:ea typeface="Arial" charset="0"/>
                         <a:cs typeface="Arial" charset="0"/>
                       </a:endParaRPr>
                     </a:p>
                   </a:txBody>
-                  <a:tcPr marL="76200" marR="76200" marT="25400" marB="25400" anchor="ctr">
+                  <a:tcPr marL="76200" marR="76200" marT="12700" marB="12700" anchor="ctr">
                     <a:lnL w="9525" cap="flat" cmpd="sng" algn="ctr">
                       <a:solidFill>
                         <a:srgbClr val="E3E6EB"/>
@@ -4206,7 +4206,7 @@
                   </a:tcPr>
                 </a:tc>
               </a:tr>
-              <a:tr h="265176">
+              <a:tr h="246888">
                 <a:tc rowSpan="2">
                   <a:txBody>
                     <a:bodyPr/>
@@ -4216,7 +4216,7 @@
                         <a:buNone/>
                       </a:pPr>
                       <a:r>
-                        <a:rPr lang="en-US" sz="1050" b="1" dirty="0">
+                        <a:rPr lang="en-US" sz="1000" b="1" dirty="0">
                           <a:solidFill>
                             <a:srgbClr val="16202E"/>
                           </a:solidFill>
@@ -4226,14 +4226,14 @@
                         </a:rPr>
                         <a:t>Normalization</a:t>
                       </a:r>
-                      <a:endParaRPr lang="en-US" sz="1050" dirty="0">
+                      <a:endParaRPr lang="en-US" sz="1000" dirty="0">
                         <a:latin typeface="Arial" charset="0"/>
                         <a:ea typeface="Arial" charset="0"/>
                         <a:cs typeface="Arial" charset="0"/>
                       </a:endParaRPr>
                     </a:p>
                   </a:txBody>
-                  <a:tcPr marL="76200" marR="76200" marT="25400" marB="25400" anchor="ctr">
+                  <a:tcPr marL="76200" marR="76200" marT="12700" marB="12700" anchor="ctr">
                     <a:lnL w="9525" cap="flat" cmpd="sng" algn="ctr">
                       <a:solidFill>
                         <a:srgbClr val="E3E6EB"/>
@@ -4284,7 +4284,7 @@
                         <a:buNone/>
                       </a:pPr>
                       <a:r>
-                        <a:rPr lang="en-US" sz="1050" dirty="0">
+                        <a:rPr lang="en-US" sz="1000" dirty="0">
                           <a:solidFill>
                             <a:srgbClr val="16202E"/>
                           </a:solidFill>
@@ -4294,14 +4294,14 @@
                         </a:rPr>
                         <a:t>Split genres into a movie_genres table</a:t>
                       </a:r>
-                      <a:endParaRPr lang="en-US" sz="1050" dirty="0">
+                      <a:endParaRPr lang="en-US" sz="1000" dirty="0">
                         <a:latin typeface="Arial" charset="0"/>
                         <a:ea typeface="Arial" charset="0"/>
                         <a:cs typeface="Arial" charset="0"/>
                       </a:endParaRPr>
                     </a:p>
                   </a:txBody>
-                  <a:tcPr marL="76200" marR="76200" marT="25400" marB="25400" anchor="ctr">
+                  <a:tcPr marL="76200" marR="76200" marT="12700" marB="12700" anchor="ctr">
                     <a:lnL w="9525" cap="flat" cmpd="sng" algn="ctr">
                       <a:solidFill>
                         <a:srgbClr val="E3E6EB"/>
@@ -4352,7 +4352,7 @@
                         <a:buNone/>
                       </a:pPr>
                       <a:r>
-                        <a:rPr lang="en-US" sz="1050" dirty="0">
+                        <a:rPr lang="en-US" sz="1000" dirty="0">
                           <a:solidFill>
                             <a:srgbClr val="4A5260"/>
                           </a:solidFill>
@@ -4362,14 +4362,14 @@
                         </a:rPr>
                         <a:t>1,084 comma-separated combos, up to 3 per title</a:t>
                       </a:r>
-                      <a:endParaRPr lang="en-US" sz="1050" dirty="0">
+                      <a:endParaRPr lang="en-US" sz="1000" dirty="0">
                         <a:latin typeface="Arial" charset="0"/>
                         <a:ea typeface="Arial" charset="0"/>
                         <a:cs typeface="Arial" charset="0"/>
                       </a:endParaRPr>
                     </a:p>
                   </a:txBody>
-                  <a:tcPr marL="76200" marR="76200" marT="25400" marB="25400" anchor="ctr">
+                  <a:tcPr marL="76200" marR="76200" marT="12700" marB="12700" anchor="ctr">
                     <a:lnL w="9525" cap="flat" cmpd="sng" algn="ctr">
                       <a:solidFill>
                         <a:srgbClr val="E3E6EB"/>
@@ -4412,7 +4412,7 @@
                   </a:tcPr>
                 </a:tc>
               </a:tr>
-              <a:tr h="265176">
+              <a:tr h="246888">
                 <a:tc vMerge="1">
                   <a:tcPr/>
                 </a:tc>
@@ -4425,7 +4425,7 @@
                         <a:buNone/>
                       </a:pPr>
                       <a:r>
-                        <a:rPr lang="en-US" sz="1050" dirty="0">
+                        <a:rPr lang="en-US" sz="1000" dirty="0">
                           <a:solidFill>
                             <a:srgbClr val="16202E"/>
                           </a:solidFill>
@@ -4435,14 +4435,14 @@
                         </a:rPr>
                         <a:t>Standardize the title fields</a:t>
                       </a:r>
-                      <a:endParaRPr lang="en-US" sz="1050" dirty="0">
+                      <a:endParaRPr lang="en-US" sz="1000" dirty="0">
                         <a:latin typeface="Arial" charset="0"/>
                         <a:ea typeface="Arial" charset="0"/>
                         <a:cs typeface="Arial" charset="0"/>
                       </a:endParaRPr>
                     </a:p>
                   </a:txBody>
-                  <a:tcPr marL="76200" marR="76200" marT="25400" marB="25400" anchor="ctr">
+                  <a:tcPr marL="76200" marR="76200" marT="12700" marB="12700" anchor="ctr">
                     <a:lnL w="9525" cap="flat" cmpd="sng" algn="ctr">
                       <a:solidFill>
                         <a:srgbClr val="E3E6EB"/>
@@ -4493,7 +4493,7 @@
                         <a:buNone/>
                       </a:pPr>
                       <a:r>
-                        <a:rPr lang="en-US" sz="1050" dirty="0">
+                        <a:rPr lang="en-US" sz="1000" dirty="0">
                           <a:solidFill>
                             <a:srgbClr val="4A5260"/>
                           </a:solidFill>
@@ -4503,14 +4503,14 @@
                         </a:rPr>
                         <a:t>14,456 titles where primary ≠ original title</a:t>
                       </a:r>
-                      <a:endParaRPr lang="en-US" sz="1050" dirty="0">
+                      <a:endParaRPr lang="en-US" sz="1000" dirty="0">
                         <a:latin typeface="Arial" charset="0"/>
                         <a:ea typeface="Arial" charset="0"/>
                         <a:cs typeface="Arial" charset="0"/>
                       </a:endParaRPr>
                     </a:p>
                   </a:txBody>
-                  <a:tcPr marL="76200" marR="76200" marT="25400" marB="25400" anchor="ctr">
+                  <a:tcPr marL="76200" marR="76200" marT="12700" marB="12700" anchor="ctr">
                     <a:lnL w="9525" cap="flat" cmpd="sng" algn="ctr">
                       <a:solidFill>
                         <a:srgbClr val="E3E6EB"/>
@@ -4553,7 +4553,7 @@
                   </a:tcPr>
                 </a:tc>
               </a:tr>
-              <a:tr h="265176">
+              <a:tr h="246888">
                 <a:tc rowSpan="2">
                   <a:txBody>
                     <a:bodyPr/>
@@ -4563,7 +4563,7 @@
                         <a:buNone/>
                       </a:pPr>
                       <a:r>
-                        <a:rPr lang="en-US" sz="1050" b="1" dirty="0">
+                        <a:rPr lang="en-US" sz="1000" b="1" dirty="0">
                           <a:solidFill>
                             <a:srgbClr val="16202E"/>
                           </a:solidFill>
@@ -4573,14 +4573,14 @@
                         </a:rPr>
                         <a:t>Null handling</a:t>
                       </a:r>
-                      <a:endParaRPr lang="en-US" sz="1050" dirty="0">
+                      <a:endParaRPr lang="en-US" sz="1000" dirty="0">
                         <a:latin typeface="Arial" charset="0"/>
                         <a:ea typeface="Arial" charset="0"/>
                         <a:cs typeface="Arial" charset="0"/>
                       </a:endParaRPr>
                     </a:p>
                   </a:txBody>
-                  <a:tcPr marL="76200" marR="76200" marT="25400" marB="25400" anchor="ctr">
+                  <a:tcPr marL="76200" marR="76200" marT="12700" marB="12700" anchor="ctr">
                     <a:lnL w="9525" cap="flat" cmpd="sng" algn="ctr">
                       <a:solidFill>
                         <a:srgbClr val="E3E6EB"/>
@@ -4631,7 +4631,7 @@
                         <a:buNone/>
                       </a:pPr>
                       <a:r>
-                        <a:rPr lang="en-US" sz="1050" dirty="0">
+                        <a:rPr lang="en-US" sz="1000" dirty="0">
                           <a:solidFill>
                             <a:srgbClr val="16202E"/>
                           </a:solidFill>
@@ -4641,14 +4641,14 @@
                         </a:rPr>
                         <a:t>Exclude nulls, never impute them</a:t>
                       </a:r>
-                      <a:endParaRPr lang="en-US" sz="1050" dirty="0">
+                      <a:endParaRPr lang="en-US" sz="1000" dirty="0">
                         <a:latin typeface="Arial" charset="0"/>
                         <a:ea typeface="Arial" charset="0"/>
                         <a:cs typeface="Arial" charset="0"/>
                       </a:endParaRPr>
                     </a:p>
                   </a:txBody>
-                  <a:tcPr marL="76200" marR="76200" marT="25400" marB="25400" anchor="ctr">
+                  <a:tcPr marL="76200" marR="76200" marT="12700" marB="12700" anchor="ctr">
                     <a:lnL w="9525" cap="flat" cmpd="sng" algn="ctr">
                       <a:solidFill>
                         <a:srgbClr val="E3E6EB"/>
@@ -4699,7 +4699,7 @@
                         <a:buNone/>
                       </a:pPr>
                       <a:r>
-                        <a:rPr lang="en-US" sz="1050" dirty="0">
+                        <a:rPr lang="en-US" sz="1000" dirty="0">
                           <a:solidFill>
                             <a:srgbClr val="4A5260"/>
                           </a:solidFill>
@@ -4709,14 +4709,14 @@
                         </a:rPr>
                         <a:t>30,765 missing runtimes, 5,359 missing genres</a:t>
                       </a:r>
-                      <a:endParaRPr lang="en-US" sz="1050" dirty="0">
+                      <a:endParaRPr lang="en-US" sz="1000" dirty="0">
                         <a:latin typeface="Arial" charset="0"/>
                         <a:ea typeface="Arial" charset="0"/>
                         <a:cs typeface="Arial" charset="0"/>
                       </a:endParaRPr>
                     </a:p>
                   </a:txBody>
-                  <a:tcPr marL="76200" marR="76200" marT="25400" marB="25400" anchor="ctr">
+                  <a:tcPr marL="76200" marR="76200" marT="12700" marB="12700" anchor="ctr">
                     <a:lnL w="9525" cap="flat" cmpd="sng" algn="ctr">
                       <a:solidFill>
                         <a:srgbClr val="E3E6EB"/>
@@ -4759,7 +4759,7 @@
                   </a:tcPr>
                 </a:tc>
               </a:tr>
-              <a:tr h="265176">
+              <a:tr h="246888">
                 <a:tc vMerge="1">
                   <a:tcPr/>
                 </a:tc>
@@ -4772,7 +4772,7 @@
                         <a:buNone/>
                       </a:pPr>
                       <a:r>
-                        <a:rPr lang="en-US" sz="1050" dirty="0">
+                        <a:rPr lang="en-US" sz="1000" dirty="0">
                           <a:solidFill>
                             <a:srgbClr val="16202E"/>
                           </a:solidFill>
@@ -4782,14 +4782,14 @@
                         </a:rPr>
                         <a:t>Label rating results as rated-only</a:t>
                       </a:r>
-                      <a:endParaRPr lang="en-US" sz="1050" dirty="0">
+                      <a:endParaRPr lang="en-US" sz="1000" dirty="0">
                         <a:latin typeface="Arial" charset="0"/>
                         <a:ea typeface="Arial" charset="0"/>
                         <a:cs typeface="Arial" charset="0"/>
                       </a:endParaRPr>
                     </a:p>
                   </a:txBody>
-                  <a:tcPr marL="76200" marR="76200" marT="25400" marB="25400" anchor="ctr">
+                  <a:tcPr marL="76200" marR="76200" marT="12700" marB="12700" anchor="ctr">
                     <a:lnL w="9525" cap="flat" cmpd="sng" algn="ctr">
                       <a:solidFill>
                         <a:srgbClr val="E3E6EB"/>
@@ -4840,7 +4840,7 @@
                         <a:buNone/>
                       </a:pPr>
                       <a:r>
-                        <a:rPr lang="en-US" sz="1050" dirty="0">
+                        <a:rPr lang="en-US" sz="1000" dirty="0">
                           <a:solidFill>
                             <a:srgbClr val="4A5260"/>
                           </a:solidFill>
@@ -4850,14 +4850,14 @@
                         </a:rPr>
                         <a:t>Only 50.9% of in-range titles have a rating</a:t>
                       </a:r>
-                      <a:endParaRPr lang="en-US" sz="1050" dirty="0">
+                      <a:endParaRPr lang="en-US" sz="1000" dirty="0">
                         <a:latin typeface="Arial" charset="0"/>
                         <a:ea typeface="Arial" charset="0"/>
                         <a:cs typeface="Arial" charset="0"/>
                       </a:endParaRPr>
                     </a:p>
                   </a:txBody>
-                  <a:tcPr marL="76200" marR="76200" marT="25400" marB="25400" anchor="ctr">
+                  <a:tcPr marL="76200" marR="76200" marT="12700" marB="12700" anchor="ctr">
                     <a:lnL w="9525" cap="flat" cmpd="sng" algn="ctr">
                       <a:solidFill>
                         <a:srgbClr val="E3E6EB"/>
@@ -4900,7 +4900,7 @@
                   </a:tcPr>
                 </a:tc>
               </a:tr>
-              <a:tr h="265176">
+              <a:tr h="246888">
                 <a:tc rowSpan="2">
                   <a:txBody>
                     <a:bodyPr/>
@@ -4910,7 +4910,7 @@
                         <a:buNone/>
                       </a:pPr>
                       <a:r>
-                        <a:rPr lang="en-US" sz="1050" b="1" dirty="0">
+                        <a:rPr lang="en-US" sz="1000" b="1" dirty="0">
                           <a:solidFill>
                             <a:srgbClr val="16202E"/>
                           </a:solidFill>
@@ -4920,14 +4920,14 @@
                         </a:rPr>
                         <a:t>Reliability</a:t>
                       </a:r>
-                      <a:endParaRPr lang="en-US" sz="1050" dirty="0">
+                      <a:endParaRPr lang="en-US" sz="1000" dirty="0">
                         <a:latin typeface="Arial" charset="0"/>
                         <a:ea typeface="Arial" charset="0"/>
                         <a:cs typeface="Arial" charset="0"/>
                       </a:endParaRPr>
                     </a:p>
                   </a:txBody>
-                  <a:tcPr marL="76200" marR="76200" marT="25400" marB="25400" anchor="ctr">
+                  <a:tcPr marL="76200" marR="76200" marT="12700" marB="12700" anchor="ctr">
                     <a:lnL w="9525" cap="flat" cmpd="sng" algn="ctr">
                       <a:solidFill>
                         <a:srgbClr val="E3E6EB"/>
@@ -4978,7 +4978,7 @@
                         <a:buNone/>
                       </a:pPr>
                       <a:r>
-                        <a:rPr lang="en-US" sz="1050" dirty="0">
+                        <a:rPr lang="en-US" sz="1000" dirty="0">
                           <a:solidFill>
                             <a:srgbClr val="16202E"/>
                           </a:solidFill>
@@ -4988,14 +4988,14 @@
                         </a:rPr>
                         <a:t>Set and state a minimum-vote floor</a:t>
                       </a:r>
-                      <a:endParaRPr lang="en-US" sz="1050" dirty="0">
+                      <a:endParaRPr lang="en-US" sz="1000" dirty="0">
                         <a:latin typeface="Arial" charset="0"/>
                         <a:ea typeface="Arial" charset="0"/>
                         <a:cs typeface="Arial" charset="0"/>
                       </a:endParaRPr>
                     </a:p>
                   </a:txBody>
-                  <a:tcPr marL="76200" marR="76200" marT="25400" marB="25400" anchor="ctr">
+                  <a:tcPr marL="76200" marR="76200" marT="12700" marB="12700" anchor="ctr">
                     <a:lnL w="9525" cap="flat" cmpd="sng" algn="ctr">
                       <a:solidFill>
                         <a:srgbClr val="E3E6EB"/>
@@ -5046,7 +5046,7 @@
                         <a:buNone/>
                       </a:pPr>
                       <a:r>
-                        <a:rPr lang="en-US" sz="1050" dirty="0">
+                        <a:rPr lang="en-US" sz="1000" dirty="0">
                           <a:solidFill>
                             <a:srgbClr val="4A5260"/>
                           </a:solidFill>
@@ -5056,14 +5056,14 @@
                         </a:rPr>
                         <a:t>12,146 titles rated on fewer than 10 votes</a:t>
                       </a:r>
-                      <a:endParaRPr lang="en-US" sz="1050" dirty="0">
+                      <a:endParaRPr lang="en-US" sz="1000" dirty="0">
                         <a:latin typeface="Arial" charset="0"/>
                         <a:ea typeface="Arial" charset="0"/>
                         <a:cs typeface="Arial" charset="0"/>
                       </a:endParaRPr>
                     </a:p>
                   </a:txBody>
-                  <a:tcPr marL="76200" marR="76200" marT="25400" marB="25400" anchor="ctr">
+                  <a:tcPr marL="76200" marR="76200" marT="12700" marB="12700" anchor="ctr">
                     <a:lnL w="9525" cap="flat" cmpd="sng" algn="ctr">
                       <a:solidFill>
                         <a:srgbClr val="E3E6EB"/>
@@ -5106,7 +5106,7 @@
                   </a:tcPr>
                 </a:tc>
               </a:tr>
-              <a:tr h="265176">
+              <a:tr h="246888">
                 <a:tc vMerge="1">
                   <a:tcPr/>
                 </a:tc>
@@ -5119,7 +5119,7 @@
                         <a:buNone/>
                       </a:pPr>
                       <a:r>
-                        <a:rPr lang="en-US" sz="1050" dirty="0">
+                        <a:rPr lang="en-US" sz="1000" dirty="0">
                           <a:solidFill>
                             <a:srgbClr val="16202E"/>
                           </a:solidFill>
@@ -5129,14 +5129,14 @@
                         </a:rPr>
                         <a:t>Bound runtimes to a plausible range</a:t>
                       </a:r>
-                      <a:endParaRPr lang="en-US" sz="1050" dirty="0">
+                      <a:endParaRPr lang="en-US" sz="1000" dirty="0">
                         <a:latin typeface="Arial" charset="0"/>
                         <a:ea typeface="Arial" charset="0"/>
                         <a:cs typeface="Arial" charset="0"/>
                       </a:endParaRPr>
                     </a:p>
                   </a:txBody>
-                  <a:tcPr marL="76200" marR="76200" marT="25400" marB="25400" anchor="ctr">
+                  <a:tcPr marL="76200" marR="76200" marT="12700" marB="12700" anchor="ctr">
                     <a:lnL w="9525" cap="flat" cmpd="sng" algn="ctr">
                       <a:solidFill>
                         <a:srgbClr val="E3E6EB"/>
@@ -5187,7 +5187,7 @@
                         <a:buNone/>
                       </a:pPr>
                       <a:r>
-                        <a:rPr lang="en-US" sz="1050" dirty="0">
+                        <a:rPr lang="en-US" sz="1000" dirty="0">
                           <a:solidFill>
                             <a:srgbClr val="4A5260"/>
                           </a:solidFill>
@@ -5197,14 +5197,14 @@
                         </a:rPr>
                         <a:t>Runtimes run from 1 to 51,420 minutes</a:t>
                       </a:r>
-                      <a:endParaRPr lang="en-US" sz="1050" dirty="0">
+                      <a:endParaRPr lang="en-US" sz="1000" dirty="0">
                         <a:latin typeface="Arial" charset="0"/>
                         <a:ea typeface="Arial" charset="0"/>
                         <a:cs typeface="Arial" charset="0"/>
                       </a:endParaRPr>
                     </a:p>
                   </a:txBody>
-                  <a:tcPr marL="76200" marR="76200" marT="25400" marB="25400" anchor="ctr">
+                  <a:tcPr marL="76200" marR="76200" marT="12700" marB="12700" anchor="ctr">
                     <a:lnL w="9525" cap="flat" cmpd="sng" algn="ctr">
                       <a:solidFill>
                         <a:srgbClr val="E3E6EB"/>
@@ -5247,8 +5247,8 @@
                   </a:tcPr>
                 </a:tc>
               </a:tr>
-              <a:tr h="265176">
-                <a:tc rowSpan="2">
+              <a:tr h="246888">
+                <a:tc rowSpan="3">
                   <a:txBody>
                     <a:bodyPr/>
                     <a:lstStyle/>
@@ -5257,7 +5257,7 @@
                         <a:buNone/>
                       </a:pPr>
                       <a:r>
-                        <a:rPr lang="en-US" sz="1050" b="1" dirty="0">
+                        <a:rPr lang="en-US" sz="1000" b="1" dirty="0">
                           <a:solidFill>
                             <a:srgbClr val="16202E"/>
                           </a:solidFill>
@@ -5267,14 +5267,14 @@
                         </a:rPr>
                         <a:t>Integrity</a:t>
                       </a:r>
-                      <a:endParaRPr lang="en-US" sz="1050" dirty="0">
+                      <a:endParaRPr lang="en-US" sz="1000" dirty="0">
                         <a:latin typeface="Arial" charset="0"/>
                         <a:ea typeface="Arial" charset="0"/>
                         <a:cs typeface="Arial" charset="0"/>
                       </a:endParaRPr>
                     </a:p>
                   </a:txBody>
-                  <a:tcPr marL="76200" marR="76200" marT="25400" marB="25400" anchor="ctr">
+                  <a:tcPr marL="76200" marR="76200" marT="12700" marB="12700" anchor="ctr">
                     <a:lnL w="9525" cap="flat" cmpd="sng" algn="ctr">
                       <a:solidFill>
                         <a:srgbClr val="E3E6EB"/>
@@ -5325,7 +5325,7 @@
                         <a:buNone/>
                       </a:pPr>
                       <a:r>
-                        <a:rPr lang="en-US" sz="1050" dirty="0">
+                        <a:rPr lang="en-US" sz="1000" dirty="0">
                           <a:solidFill>
                             <a:srgbClr val="16202E"/>
                           </a:solidFill>
@@ -5335,14 +5335,14 @@
                         </a:rPr>
                         <a:t>Review duplicate titles</a:t>
                       </a:r>
-                      <a:endParaRPr lang="en-US" sz="1050" dirty="0">
+                      <a:endParaRPr lang="en-US" sz="1000" dirty="0">
                         <a:latin typeface="Arial" charset="0"/>
                         <a:ea typeface="Arial" charset="0"/>
                         <a:cs typeface="Arial" charset="0"/>
                       </a:endParaRPr>
                     </a:p>
                   </a:txBody>
-                  <a:tcPr marL="76200" marR="76200" marT="25400" marB="25400" anchor="ctr">
+                  <a:tcPr marL="76200" marR="76200" marT="12700" marB="12700" anchor="ctr">
                     <a:lnL w="9525" cap="flat" cmpd="sng" algn="ctr">
                       <a:solidFill>
                         <a:srgbClr val="E3E6EB"/>
@@ -5393,7 +5393,7 @@
                         <a:buNone/>
                       </a:pPr>
                       <a:r>
-                        <a:rPr lang="en-US" sz="1050" dirty="0">
+                        <a:rPr lang="en-US" sz="1000" dirty="0">
                           <a:solidFill>
                             <a:srgbClr val="4A5260"/>
                           </a:solidFill>
@@ -5403,14 +5403,14 @@
                         </a:rPr>
                         <a:t>1,859 title-and-year pairs appear twice or more</a:t>
                       </a:r>
-                      <a:endParaRPr lang="en-US" sz="1050" dirty="0">
+                      <a:endParaRPr lang="en-US" sz="1000" dirty="0">
                         <a:latin typeface="Arial" charset="0"/>
                         <a:ea typeface="Arial" charset="0"/>
                         <a:cs typeface="Arial" charset="0"/>
                       </a:endParaRPr>
                     </a:p>
                   </a:txBody>
-                  <a:tcPr marL="76200" marR="76200" marT="25400" marB="25400" anchor="ctr">
+                  <a:tcPr marL="76200" marR="76200" marT="12700" marB="12700" anchor="ctr">
                     <a:lnL w="9525" cap="flat" cmpd="sng" algn="ctr">
                       <a:solidFill>
                         <a:srgbClr val="E3E6EB"/>
@@ -5453,7 +5453,7 @@
                   </a:tcPr>
                 </a:tc>
               </a:tr>
-              <a:tr h="265176">
+              <a:tr h="246888">
                 <a:tc vMerge="1">
                   <a:tcPr/>
                 </a:tc>
@@ -5466,7 +5466,7 @@
                         <a:buNone/>
                       </a:pPr>
                       <a:r>
-                        <a:rPr lang="en-US" sz="1050" dirty="0">
+                        <a:rPr lang="en-US" sz="1000" dirty="0">
                           <a:solidFill>
                             <a:srgbClr val="16202E"/>
                           </a:solidFill>
@@ -5476,14 +5476,14 @@
                         </a:rPr>
                         <a:t>Declare primary and foreign keys</a:t>
                       </a:r>
-                      <a:endParaRPr lang="en-US" sz="1050" dirty="0">
+                      <a:endParaRPr lang="en-US" sz="1000" dirty="0">
                         <a:latin typeface="Arial" charset="0"/>
                         <a:ea typeface="Arial" charset="0"/>
                         <a:cs typeface="Arial" charset="0"/>
                       </a:endParaRPr>
                     </a:p>
                   </a:txBody>
-                  <a:tcPr marL="76200" marR="76200" marT="25400" marB="25400" anchor="ctr">
+                  <a:tcPr marL="76200" marR="76200" marT="12700" marB="12700" anchor="ctr">
                     <a:lnL w="9525" cap="flat" cmpd="sng" algn="ctr">
                       <a:solidFill>
                         <a:srgbClr val="E3E6EB"/>
@@ -5534,7 +5534,7 @@
                         <a:buNone/>
                       </a:pPr>
                       <a:r>
-                        <a:rPr lang="en-US" sz="1050" dirty="0">
+                        <a:rPr lang="en-US" sz="1000" dirty="0">
                           <a:solidFill>
                             <a:srgbClr val="4A5260"/>
                           </a:solidFill>
@@ -5544,14 +5544,155 @@
                         </a:rPr>
                         <a:t>No keys on movie_id or person_id</a:t>
                       </a:r>
-                      <a:endParaRPr lang="en-US" sz="1050" dirty="0">
+                      <a:endParaRPr lang="en-US" sz="1000" dirty="0">
                         <a:latin typeface="Arial" charset="0"/>
                         <a:ea typeface="Arial" charset="0"/>
                         <a:cs typeface="Arial" charset="0"/>
                       </a:endParaRPr>
                     </a:p>
                   </a:txBody>
-                  <a:tcPr marL="76200" marR="76200" marT="25400" marB="25400" anchor="ctr">
+                  <a:tcPr marL="76200" marR="76200" marT="12700" marB="12700" anchor="ctr">
+                    <a:lnL w="9525" cap="flat" cmpd="sng" algn="ctr">
+                      <a:solidFill>
+                        <a:srgbClr val="E3E6EB"/>
+                      </a:solidFill>
+                      <a:prstDash val="solid"/>
+                      <a:round/>
+                      <a:headEnd type="none" w="med" len="med"/>
+                      <a:tailEnd type="none" w="med" len="med"/>
+                    </a:lnL>
+                    <a:lnR w="9525" cap="flat" cmpd="sng" algn="ctr">
+                      <a:solidFill>
+                        <a:srgbClr val="E3E6EB"/>
+                      </a:solidFill>
+                      <a:prstDash val="solid"/>
+                      <a:round/>
+                      <a:headEnd type="none" w="med" len="med"/>
+                      <a:tailEnd type="none" w="med" len="med"/>
+                    </a:lnR>
+                    <a:lnT w="9525" cap="flat" cmpd="sng" algn="ctr">
+                      <a:solidFill>
+                        <a:srgbClr val="E3E6EB"/>
+                      </a:solidFill>
+                      <a:prstDash val="solid"/>
+                      <a:round/>
+                      <a:headEnd type="none" w="med" len="med"/>
+                      <a:tailEnd type="none" w="med" len="med"/>
+                    </a:lnT>
+                    <a:lnB w="9525" cap="flat" cmpd="sng" algn="ctr">
+                      <a:solidFill>
+                        <a:srgbClr val="E3E6EB"/>
+                      </a:solidFill>
+                      <a:prstDash val="solid"/>
+                      <a:round/>
+                      <a:headEnd type="none" w="med" len="med"/>
+                      <a:tailEnd type="none" w="med" len="med"/>
+                    </a:lnB>
+                    <a:solidFill>
+                      <a:srgbClr val="FFFFFF"/>
+                    </a:solidFill>
+                  </a:tcPr>
+                </a:tc>
+              </a:tr>
+              <a:tr h="246888">
+                <a:tc vMerge="1">
+                  <a:tcPr/>
+                </a:tc>
+                <a:tc>
+                  <a:txBody>
+                    <a:bodyPr/>
+                    <a:lstStyle/>
+                    <a:p>
+                      <a:pPr indent="0" marL="0">
+                        <a:buNone/>
+                      </a:pPr>
+                      <a:r>
+                        <a:rPr lang="en-US" sz="1000" dirty="0">
+                          <a:solidFill>
+                            <a:srgbClr val="16202E"/>
+                          </a:solidFill>
+                          <a:latin typeface="Arial" pitchFamily="34" charset="0"/>
+                          <a:ea typeface="Arial" pitchFamily="34" charset="-122"/>
+                          <a:cs typeface="Arial" pitchFamily="34" charset="-120"/>
+                        </a:rPr>
+                        <a:t>De-duplicate the directors table</a:t>
+                      </a:r>
+                      <a:endParaRPr lang="en-US" sz="1000" dirty="0">
+                        <a:latin typeface="Arial" charset="0"/>
+                        <a:ea typeface="Arial" charset="0"/>
+                        <a:cs typeface="Arial" charset="0"/>
+                      </a:endParaRPr>
+                    </a:p>
+                  </a:txBody>
+                  <a:tcPr marL="76200" marR="76200" marT="12700" marB="12700" anchor="ctr">
+                    <a:lnL w="9525" cap="flat" cmpd="sng" algn="ctr">
+                      <a:solidFill>
+                        <a:srgbClr val="E3E6EB"/>
+                      </a:solidFill>
+                      <a:prstDash val="solid"/>
+                      <a:round/>
+                      <a:headEnd type="none" w="med" len="med"/>
+                      <a:tailEnd type="none" w="med" len="med"/>
+                    </a:lnL>
+                    <a:lnR w="9525" cap="flat" cmpd="sng" algn="ctr">
+                      <a:solidFill>
+                        <a:srgbClr val="E3E6EB"/>
+                      </a:solidFill>
+                      <a:prstDash val="solid"/>
+                      <a:round/>
+                      <a:headEnd type="none" w="med" len="med"/>
+                      <a:tailEnd type="none" w="med" len="med"/>
+                    </a:lnR>
+                    <a:lnT w="9525" cap="flat" cmpd="sng" algn="ctr">
+                      <a:solidFill>
+                        <a:srgbClr val="E3E6EB"/>
+                      </a:solidFill>
+                      <a:prstDash val="solid"/>
+                      <a:round/>
+                      <a:headEnd type="none" w="med" len="med"/>
+                      <a:tailEnd type="none" w="med" len="med"/>
+                    </a:lnT>
+                    <a:lnB w="9525" cap="flat" cmpd="sng" algn="ctr">
+                      <a:solidFill>
+                        <a:srgbClr val="E3E6EB"/>
+                      </a:solidFill>
+                      <a:prstDash val="solid"/>
+                      <a:round/>
+                      <a:headEnd type="none" w="med" len="med"/>
+                      <a:tailEnd type="none" w="med" len="med"/>
+                    </a:lnB>
+                    <a:solidFill>
+                      <a:srgbClr val="FFFFFF"/>
+                    </a:solidFill>
+                  </a:tcPr>
+                </a:tc>
+                <a:tc>
+                  <a:txBody>
+                    <a:bodyPr/>
+                    <a:lstStyle/>
+                    <a:p>
+                      <a:pPr indent="0" marL="0">
+                        <a:buNone/>
+                      </a:pPr>
+                      <a:r>
+                        <a:rPr lang="en-US" sz="1000" dirty="0">
+                          <a:solidFill>
+                            <a:srgbClr val="4A5260"/>
+                          </a:solidFill>
+                          <a:latin typeface="Arial" pitchFamily="34" charset="0"/>
+                          <a:ea typeface="Arial" pitchFamily="34" charset="-122"/>
+                          <a:cs typeface="Arial" pitchFamily="34" charset="-120"/>
+                        </a:rPr>
+                        <a:t>43.8% of its rows repeat a director–film pair</a:t>
+                      </a:r>
+                      <a:endParaRPr lang="en-US" sz="1000" dirty="0">
+                        <a:latin typeface="Arial" charset="0"/>
+                        <a:ea typeface="Arial" charset="0"/>
+                        <a:cs typeface="Arial" charset="0"/>
+                      </a:endParaRPr>
+                    </a:p>
+                  </a:txBody>
+                  <a:tcPr marL="76200" marR="76200" marT="12700" marB="12700" anchor="ctr">
                     <a:lnL w="9525" cap="flat" cmpd="sng" algn="ctr">
                       <a:solidFill>
                         <a:srgbClr val="E3E6EB"/>
@@ -5606,7 +5747,7 @@
         </p:nvSpPr>
         <p:spPr>
           <a:xfrm>
-            <a:off x="457200" y="4407408"/>
+            <a:off x="457200" y="4526280"/>
             <a:ext cx="8229600" cy="274320"/>
           </a:xfrm>
           <a:prstGeom prst="rect">

</xml_diff>